<commit_message>
Apresentação: corrige rótulo de arestas e legenda do panorama
O "106" do slide de validação é o número de linhas da aba Techs, não de
arestas do grafo: cada linha com entrada e saída gera duas setas, e o
grafo real tem 175 arestas (78 de entrada + 97 de saída). O rótulo passa a
"ligações declaradas", mantendo o número alinhado ao relatório final.

A legenda da Figura 7 dizia "combustíveis primários e secundários", mas o
recorte também mostra combustíveis do estágio 3; passa a dizer apenas que
é um recorte do diagrama gerado.

Demais números recontados direto da planilha, do M e do JSON do Deneb e
conferidos (70 combustíveis, 101 tecnologias, 4 fluxos reversos, 556
linhas de M, 16 marcas, 2 px / 45 px).
</commit_message>
<xml_diff>
--- a/Apresentacao/Apresentacao_XVI_Seminario_PIBITI.pptx
+++ b/Apresentacao/Apresentacao_XVI_Seminario_PIBITI.pptx
@@ -820,7 +820,7 @@
           <a:lstStyle/>
           <a:p>
             <a:r>
-              <a:t>[~45 s] A ferramenta foi validada num sistema energético nacional estilizado com 70 combustíveis em 5 estágios, 101 tecnologias e 106 arestas, incluindo 25 tecnologias-fonte e 4 fluxos reversos. Também foi testada com bases de topologia aleatória, com casos patológicos, para confirmar que o layout não depende deste sistema específico. A figura é só um recorte: o diagrama inteiro tem milhares de pixels nos dois eixos, por isso zoom e destaque são essenciais. O ganho principal: o que levava dias à mão agora se atualiza em segundos, e manter o diagrama sincronizado com o modelo passa a custar praticamente zero.</a:t>
+              <a:t>[~45 s] A ferramenta foi validada num sistema energético nacional estilizado com 70 combustíveis em 5 estágios, 101 tecnologias e 106 ligações declaradas na planilha, incluindo 25 tecnologias-fonte e 4 fluxos reversos. Também foi testada com bases de topologia aleatória, com casos patológicos, para confirmar que o layout não depende deste sistema específico. A figura é só um recorte: o diagrama inteiro tem milhares de pixels nos dois eixos, por isso zoom e destaque são essenciais. O ganho principal: o que levava dias à mão agora se atualiza em segundos, e manter o diagrama sincronizado com o modelo passa a custar praticamente zero.</a:t>
             </a:r>
           </a:p>
         </p:txBody>
@@ -11923,7 +11923,7 @@
                 </a:solidFill>
                 <a:latin typeface="Calibri"/>
               </a:rPr>
-              <a:t>Recorte do diagrama gerado: combustíveis primários e secundários</a:t>
+              <a:t>Recorte do diagrama gerado automaticamente</a:t>
             </a:r>
           </a:p>
         </p:txBody>
@@ -12146,7 +12146,7 @@
       </p:sp>
       <p:sp>
         <p:nvSpPr>
-          <p:cNvPr id="9" name="Stat arestas"/>
+          <p:cNvPr id="9" name="Stat ligações declaradas"/>
           <p:cNvSpPr/>
           <p:nvPr/>
         </p:nvSpPr>
@@ -12211,7 +12211,7 @@
                 </a:solidFill>
                 <a:latin typeface="Calibri"/>
               </a:rPr>
-              <a:t>arestas</a:t>
+              <a:t>ligações declaradas</a:t>
             </a:r>
           </a:p>
         </p:txBody>

</xml_diff>

<commit_message>
Apresentação: link do repositório com o novo nome (Freddieij/DDFE)
</commit_message>
<xml_diff>
--- a/Apresentacao/Apresentacao_XVI_Seminario_PIBITI.pptx
+++ b/Apresentacao/Apresentacao_XVI_Seminario_PIBITI.pptx
@@ -13458,7 +13458,7 @@
                 <a:latin typeface="Calibri"/>
                 <a:hlinkClick r:id="rId3"/>
               </a:rPr>
-              <a:t>github.com/Freddieij/Power_BI_Borba</a:t>
+              <a:t>github.com/Freddieij/DDFE</a:t>
             </a:r>
           </a:p>
         </p:txBody>
@@ -13674,7 +13674,7 @@
                 <a:cs typeface="Arial"/>
                 <a:sym typeface="Arial"/>
               </a:rPr>
-              <a:t>github.com/Freddieij/Power_BI_Borba  ·  Apoio: CNPq (PIBITI/PIBINOVA UFF 2025-2026)</a:t>
+              <a:t>github.com/Freddieij/DDFE  ·  Apoio: CNPq (PIBITI/PIBINOVA UFF 2025-2026)</a:t>
             </a:r>
             <a:endParaRPr sz="2400"/>
           </a:p>
@@ -16688,30 +16688,7 @@
                 <a:latin typeface="Calibri"/>
                 <a:hlinkClick r:id="rId3"/>
               </a:rPr>
-              <a:t>github.com/Freddieij/</a:t>
-            </a:r>
-          </a:p>
-          <a:p>
-            <a:pPr algn="l">
-              <a:lnSpc>
-                <a:spcPct val="100000"/>
-              </a:lnSpc>
-              <a:spcBef>
-                <a:spcPts val="200"/>
-              </a:spcBef>
-              <a:spcAft>
-                <a:spcPts val="0"/>
-              </a:spcAft>
-            </a:pPr>
-            <a:r>
-              <a:rPr sz="1300" b="0" i="0">
-                <a:solidFill>
-                  <a:srgbClr val="0B5394"/>
-                </a:solidFill>
-                <a:latin typeface="Calibri"/>
-                <a:hlinkClick r:id="rId3"/>
-              </a:rPr>
-              <a:t>Power_BI_Borba</a:t>
+              <a:t>github.com/Freddieij/DDFE</a:t>
             </a:r>
           </a:p>
         </p:txBody>

</xml_diff>

<commit_message>
Apresentação: sinaliza o trecho omitido no zoom da Figura 4
A marca "//" do recorte era lida como parte do diagrama, colada à coluna
do estágio 3. O vão vira uma faixa cinza com as linhas de retorno
pontilhadas e a legenda "trecho omitido", deixando claro que ali foram
suprimidas colunas para ampliar a figura.
</commit_message>
<xml_diff>
--- a/Apresentacao/Apresentacao_XVI_Seminario_PIBITI.pptx
+++ b/Apresentacao/Apresentacao_XVI_Seminario_PIBITI.pptx
@@ -1342,7 +1342,7 @@
           <a:lstStyle/>
           <a:p>
             <a:r>
-              <a:t>[~45 s] Um caso que os visuais prontos não tratam é a conexão de retorno. A termelétrica a gás natural usa gás processado, que está no estágio 3, para gerar eletricidade, que está no estágio 2. Isso não é erro do modelo: a energia segue o sentido normal, do gás para a eletricidade. Mas, como as colunas seguem o estágio, a entrada fica à direita da saída, e a linha precisa voltar para a esquerda, contornando as caixas. O cálculo detecta esses casos comparando os estágios de entrada e saída, sem o usuário declarar nada. No sistema de validação há quatro casos, todos desenhados automaticamente.</a:t>
+              <a:t>[~45 s] Um caso que os visuais prontos não tratam é a conexão de retorno. A termelétrica a gás natural usa gás processado, que está no estágio 3, para gerar eletricidade, que está no estágio 2. Isso não é erro do modelo: a energia segue o sentido normal, do gás para a eletricidade. Mas, como as colunas seguem o estágio, a entrada fica à direita da saída, e a linha precisa voltar para a esquerda, contornando as caixas. A faixa cinza é só um trecho omitido da figura, onde ficam outras colunas do estágio 3, para caber o zoom. O cálculo detecta esses casos comparando os estágios de entrada e saída, sem o usuário declarar nada. No sistema de validação há quatro casos, todos desenhados automaticamente.</a:t>
             </a:r>
           </a:p>
         </p:txBody>
@@ -19266,7 +19266,7 @@
         </p:nvSpPr>
         <p:spPr>
           <a:xfrm>
-            <a:off x="5956567" y="1737360"/>
+            <a:off x="6112658" y="1737360"/>
             <a:ext cx="3200400" cy="320040"/>
           </a:xfrm>
           <a:prstGeom prst="rect">
@@ -19320,7 +19320,7 @@
         <p:spPr>
           <a:xfrm>
             <a:off x="914400" y="2103120"/>
-            <a:ext cx="10360152" cy="1832291"/>
+            <a:ext cx="10360152" cy="1702820"/>
           </a:xfrm>
           <a:prstGeom prst="rect">
             <a:avLst/>
@@ -19340,7 +19340,7 @@
         </p:nvSpPr>
         <p:spPr>
           <a:xfrm>
-            <a:off x="2237121" y="3981131"/>
+            <a:off x="2053200" y="3851660"/>
             <a:ext cx="2560320" cy="320040"/>
           </a:xfrm>
           <a:prstGeom prst="rect">
@@ -19385,8 +19385,8 @@
         </p:nvSpPr>
         <p:spPr>
           <a:xfrm>
-            <a:off x="5781834" y="3981131"/>
-            <a:ext cx="2560320" cy="320040"/>
+            <a:off x="5530322" y="3851660"/>
+            <a:ext cx="2194560" cy="320040"/>
           </a:xfrm>
           <a:prstGeom prst="rect">
             <a:avLst/>
@@ -19424,7 +19424,52 @@
       </p:sp>
       <p:sp>
         <p:nvSpPr>
-          <p:cNvPr id="54" name="O que acontece"/>
+          <p:cNvPr id="54" name="TextBox 53"/>
+          <p:cNvSpPr txBox="1"/>
+          <p:nvPr/>
+        </p:nvSpPr>
+        <p:spPr>
+          <a:xfrm>
+            <a:off x="7753999" y="3851660"/>
+            <a:ext cx="1280160" cy="320040"/>
+          </a:xfrm>
+          <a:prstGeom prst="rect">
+            <a:avLst/>
+          </a:prstGeom>
+          <a:noFill/>
+        </p:spPr>
+        <p:txBody>
+          <a:bodyPr wrap="square" anchor="t" lIns="0" rIns="0" tIns="0" bIns="0">
+            <a:spAutoFit/>
+          </a:bodyPr>
+          <a:lstStyle/>
+          <a:p>
+            <a:pPr algn="ctr">
+              <a:lnSpc>
+                <a:spcPct val="100000"/>
+              </a:lnSpc>
+              <a:spcBef>
+                <a:spcPts val="0"/>
+              </a:spcBef>
+              <a:spcAft>
+                <a:spcPts val="0"/>
+              </a:spcAft>
+            </a:pPr>
+            <a:r>
+              <a:rPr sz="1200" b="0" i="1">
+                <a:solidFill>
+                  <a:srgbClr val="595959"/>
+                </a:solidFill>
+                <a:latin typeface="Calibri"/>
+              </a:rPr>
+              <a:t>↑  trecho omitido</a:t>
+            </a:r>
+          </a:p>
+        </p:txBody>
+      </p:sp>
+      <p:sp>
+        <p:nvSpPr>
+          <p:cNvPr id="55" name="O que acontece"/>
           <p:cNvSpPr/>
           <p:nvPr/>
         </p:nvSpPr>
@@ -19496,7 +19541,7 @@
       </p:sp>
       <p:sp>
         <p:nvSpPr>
-          <p:cNvPr id="55" name="Não é erro do modelo"/>
+          <p:cNvPr id="56" name="Não é erro do modelo"/>
           <p:cNvSpPr/>
           <p:nvPr/>
         </p:nvSpPr>
@@ -19568,7 +19613,7 @@
       </p:sp>
       <p:sp>
         <p:nvSpPr>
-          <p:cNvPr id="56" name="Detecção automática"/>
+          <p:cNvPr id="57" name="Detecção automática"/>
           <p:cNvSpPr/>
           <p:nvPr/>
         </p:nvSpPr>

</xml_diff>